<commit_message>
updates to various courses
</commit_message>
<xml_diff>
--- a/Deep Learning/Aakash Taught/11. 12-April-2026/DNN_M7_RNN.pptx
+++ b/Deep Learning/Aakash Taught/11. 12-April-2026/DNN_M7_RNN.pptx
@@ -40803,472 +40803,6 @@
 </a:theme>
 </file>
 
-<file path=customXml/item1.xml><?xml version="1.0" encoding="utf-8"?>
-<ct:contentTypeSchema xmlns:ct="http://schemas.microsoft.com/office/2006/metadata/contentType" xmlns:ma="http://schemas.microsoft.com/office/2006/metadata/properties/metaAttributes" ct:_="" ma:_="" ma:contentTypeName="Document" ma:contentTypeID="0x010100483247868A9EF043AAFD763B509A33CB" ma:contentTypeVersion="32" ma:contentTypeDescription="Create a new document." ma:contentTypeScope="" ma:versionID="49e29cc773250fb22efa7541fc8a4712">
-  <xsd:schema xmlns:xsd="http://www.w3.org/2001/XMLSchema" xmlns:xs="http://www.w3.org/2001/XMLSchema" xmlns:p="http://schemas.microsoft.com/office/2006/metadata/properties" xmlns:ns2="921d7e3d-ccf6-4c0a-83b2-6e8132303dda" xmlns:ns3="9e209dda-a78e-49a0-9b2f-f7ca81c34b7c" targetNamespace="http://schemas.microsoft.com/office/2006/metadata/properties" ma:root="true" ma:fieldsID="8e323d0c1f05f1d80d7a271d7d64525c" ns2:_="" ns3:_="">
-    <xsd:import namespace="921d7e3d-ccf6-4c0a-83b2-6e8132303dda"/>
-    <xsd:import namespace="9e209dda-a78e-49a0-9b2f-f7ca81c34b7c"/>
-    <xsd:element name="properties">
-      <xsd:complexType>
-        <xsd:sequence>
-          <xsd:element name="documentManagement">
-            <xsd:complexType>
-              <xsd:all>
-                <xsd:element ref="ns2:NotebookType" minOccurs="0"/>
-                <xsd:element ref="ns2:FolderType" minOccurs="0"/>
-                <xsd:element ref="ns2:CultureName" minOccurs="0"/>
-                <xsd:element ref="ns2:AppVersion" minOccurs="0"/>
-                <xsd:element ref="ns2:TeamsChannelId" minOccurs="0"/>
-                <xsd:element ref="ns2:Owner" minOccurs="0"/>
-                <xsd:element ref="ns2:Math_Settings" minOccurs="0"/>
-                <xsd:element ref="ns2:DefaultSectionNames" minOccurs="0"/>
-                <xsd:element ref="ns2:Templates" minOccurs="0"/>
-                <xsd:element ref="ns2:Teachers" minOccurs="0"/>
-                <xsd:element ref="ns2:Students" minOccurs="0"/>
-                <xsd:element ref="ns2:Student_Groups" minOccurs="0"/>
-                <xsd:element ref="ns2:Distribution_Groups" minOccurs="0"/>
-                <xsd:element ref="ns2:LMS_Mappings" minOccurs="0"/>
-                <xsd:element ref="ns2:Invited_Teachers" minOccurs="0"/>
-                <xsd:element ref="ns2:Invited_Students" minOccurs="0"/>
-                <xsd:element ref="ns2:Self_Registration_Enabled" minOccurs="0"/>
-                <xsd:element ref="ns2:Has_Teacher_Only_SectionGroup" minOccurs="0"/>
-                <xsd:element ref="ns2:Is_Collaboration_Space_Locked" minOccurs="0"/>
-                <xsd:element ref="ns2:IsNotebookLocked" minOccurs="0"/>
-                <xsd:element ref="ns2:Teams_Channel_Section_Location" minOccurs="0"/>
-                <xsd:element ref="ns2:MediaServiceMetadata" minOccurs="0"/>
-                <xsd:element ref="ns2:MediaServiceFastMetadata" minOccurs="0"/>
-                <xsd:element ref="ns2:MediaServiceSearchProperties" minOccurs="0"/>
-                <xsd:element ref="ns2:MediaServiceDateTaken" minOccurs="0"/>
-                <xsd:element ref="ns2:MediaServiceGenerationTime" minOccurs="0"/>
-                <xsd:element ref="ns2:MediaServiceEventHashCode" minOccurs="0"/>
-                <xsd:element ref="ns2:MediaLengthInSeconds" minOccurs="0"/>
-                <xsd:element ref="ns2:lcf76f155ced4ddcb4097134ff3c332f" minOccurs="0"/>
-                <xsd:element ref="ns3:TaxCatchAll" minOccurs="0"/>
-                <xsd:element ref="ns2:MediaServiceOCR" minOccurs="0"/>
-              </xsd:all>
-            </xsd:complexType>
-          </xsd:element>
-        </xsd:sequence>
-      </xsd:complexType>
-    </xsd:element>
-  </xsd:schema>
-  <xsd:schema xmlns:xsd="http://www.w3.org/2001/XMLSchema" xmlns:xs="http://www.w3.org/2001/XMLSchema" xmlns:dms="http://schemas.microsoft.com/office/2006/documentManagement/types" xmlns:pc="http://schemas.microsoft.com/office/infopath/2007/PartnerControls" targetNamespace="921d7e3d-ccf6-4c0a-83b2-6e8132303dda" elementFormDefault="qualified">
-    <xsd:import namespace="http://schemas.microsoft.com/office/2006/documentManagement/types"/>
-    <xsd:import namespace="http://schemas.microsoft.com/office/infopath/2007/PartnerControls"/>
-    <xsd:element name="NotebookType" ma:index="8" nillable="true" ma:displayName="Notebook Type" ma:internalName="NotebookType">
-      <xsd:simpleType>
-        <xsd:restriction base="dms:Text"/>
-      </xsd:simpleType>
-    </xsd:element>
-    <xsd:element name="FolderType" ma:index="9" nillable="true" ma:displayName="Folder Type" ma:internalName="FolderType">
-      <xsd:simpleType>
-        <xsd:restriction base="dms:Text"/>
-      </xsd:simpleType>
-    </xsd:element>
-    <xsd:element name="CultureName" ma:index="10" nillable="true" ma:displayName="Culture Name" ma:internalName="CultureName">
-      <xsd:simpleType>
-        <xsd:restriction base="dms:Text"/>
-      </xsd:simpleType>
-    </xsd:element>
-    <xsd:element name="AppVersion" ma:index="11" nillable="true" ma:displayName="App Version" ma:internalName="AppVersion">
-      <xsd:simpleType>
-        <xsd:restriction base="dms:Text"/>
-      </xsd:simpleType>
-    </xsd:element>
-    <xsd:element name="TeamsChannelId" ma:index="12" nillable="true" ma:displayName="Teams Channel Id" ma:internalName="TeamsChannelId">
-      <xsd:simpleType>
-        <xsd:restriction base="dms:Text"/>
-      </xsd:simpleType>
-    </xsd:element>
-    <xsd:element name="Owner" ma:index="13" nillable="true" ma:displayName="Owner" ma:internalName="Owner">
-      <xsd:complexType>
-        <xsd:complexContent>
-          <xsd:extension base="dms:User">
-            <xsd:sequence>
-              <xsd:element name="UserInfo" minOccurs="0" maxOccurs="unbounded">
-                <xsd:complexType>
-                  <xsd:sequence>
-                    <xsd:element name="DisplayName" type="xsd:string" minOccurs="0"/>
-                    <xsd:element name="AccountId" type="dms:UserId" minOccurs="0" nillable="true"/>
-                    <xsd:element name="AccountType" type="xsd:string" minOccurs="0"/>
-                  </xsd:sequence>
-                </xsd:complexType>
-              </xsd:element>
-            </xsd:sequence>
-          </xsd:extension>
-        </xsd:complexContent>
-      </xsd:complexType>
-    </xsd:element>
-    <xsd:element name="Math_Settings" ma:index="14" nillable="true" ma:displayName="Math Settings" ma:internalName="Math_Settings">
-      <xsd:simpleType>
-        <xsd:restriction base="dms:Text"/>
-      </xsd:simpleType>
-    </xsd:element>
-    <xsd:element name="DefaultSectionNames" ma:index="15" nillable="true" ma:displayName="Default Section Names" ma:internalName="DefaultSectionNames">
-      <xsd:simpleType>
-        <xsd:restriction base="dms:Note">
-          <xsd:maxLength value="255"/>
-        </xsd:restriction>
-      </xsd:simpleType>
-    </xsd:element>
-    <xsd:element name="Templates" ma:index="16" nillable="true" ma:displayName="Templates" ma:internalName="Templates">
-      <xsd:simpleType>
-        <xsd:restriction base="dms:Note">
-          <xsd:maxLength value="255"/>
-        </xsd:restriction>
-      </xsd:simpleType>
-    </xsd:element>
-    <xsd:element name="Teachers" ma:index="17" nillable="true" ma:displayName="Teachers" ma:internalName="Teachers">
-      <xsd:complexType>
-        <xsd:complexContent>
-          <xsd:extension base="dms:UserMulti">
-            <xsd:sequence>
-              <xsd:element name="UserInfo" minOccurs="0" maxOccurs="unbounded">
-                <xsd:complexType>
-                  <xsd:sequence>
-                    <xsd:element name="DisplayName" type="xsd:string" minOccurs="0"/>
-                    <xsd:element name="AccountId" type="dms:UserId" minOccurs="0" nillable="true"/>
-                    <xsd:element name="AccountType" type="xsd:string" minOccurs="0"/>
-                  </xsd:sequence>
-                </xsd:complexType>
-              </xsd:element>
-            </xsd:sequence>
-          </xsd:extension>
-        </xsd:complexContent>
-      </xsd:complexType>
-    </xsd:element>
-    <xsd:element name="Students" ma:index="18" nillable="true" ma:displayName="Students" ma:internalName="Students">
-      <xsd:complexType>
-        <xsd:complexContent>
-          <xsd:extension base="dms:UserMulti">
-            <xsd:sequence>
-              <xsd:element name="UserInfo" minOccurs="0" maxOccurs="unbounded">
-                <xsd:complexType>
-                  <xsd:sequence>
-                    <xsd:element name="DisplayName" type="xsd:string" minOccurs="0"/>
-                    <xsd:element name="AccountId" type="dms:UserId" minOccurs="0" nillable="true"/>
-                    <xsd:element name="AccountType" type="xsd:string" minOccurs="0"/>
-                  </xsd:sequence>
-                </xsd:complexType>
-              </xsd:element>
-            </xsd:sequence>
-          </xsd:extension>
-        </xsd:complexContent>
-      </xsd:complexType>
-    </xsd:element>
-    <xsd:element name="Student_Groups" ma:index="19" nillable="true" ma:displayName="Student Groups" ma:internalName="Student_Groups">
-      <xsd:complexType>
-        <xsd:complexContent>
-          <xsd:extension base="dms:UserMulti">
-            <xsd:sequence>
-              <xsd:element name="UserInfo" minOccurs="0" maxOccurs="unbounded">
-                <xsd:complexType>
-                  <xsd:sequence>
-                    <xsd:element name="DisplayName" type="xsd:string" minOccurs="0"/>
-                    <xsd:element name="AccountId" type="dms:UserId" minOccurs="0" nillable="true"/>
-                    <xsd:element name="AccountType" type="xsd:string" minOccurs="0"/>
-                  </xsd:sequence>
-                </xsd:complexType>
-              </xsd:element>
-            </xsd:sequence>
-          </xsd:extension>
-        </xsd:complexContent>
-      </xsd:complexType>
-    </xsd:element>
-    <xsd:element name="Distribution_Groups" ma:index="20" nillable="true" ma:displayName="Distribution Groups" ma:internalName="Distribution_Groups">
-      <xsd:simpleType>
-        <xsd:restriction base="dms:Note">
-          <xsd:maxLength value="255"/>
-        </xsd:restriction>
-      </xsd:simpleType>
-    </xsd:element>
-    <xsd:element name="LMS_Mappings" ma:index="21" nillable="true" ma:displayName="LMS Mappings" ma:internalName="LMS_Mappings">
-      <xsd:simpleType>
-        <xsd:restriction base="dms:Note">
-          <xsd:maxLength value="255"/>
-        </xsd:restriction>
-      </xsd:simpleType>
-    </xsd:element>
-    <xsd:element name="Invited_Teachers" ma:index="22" nillable="true" ma:displayName="Invited Teachers" ma:internalName="Invited_Teachers">
-      <xsd:simpleType>
-        <xsd:restriction base="dms:Note">
-          <xsd:maxLength value="255"/>
-        </xsd:restriction>
-      </xsd:simpleType>
-    </xsd:element>
-    <xsd:element name="Invited_Students" ma:index="23" nillable="true" ma:displayName="Invited Students" ma:internalName="Invited_Students">
-      <xsd:simpleType>
-        <xsd:restriction base="dms:Note">
-          <xsd:maxLength value="255"/>
-        </xsd:restriction>
-      </xsd:simpleType>
-    </xsd:element>
-    <xsd:element name="Self_Registration_Enabled" ma:index="24" nillable="true" ma:displayName="Self Registration Enabled" ma:internalName="Self_Registration_Enabled">
-      <xsd:simpleType>
-        <xsd:restriction base="dms:Boolean"/>
-      </xsd:simpleType>
-    </xsd:element>
-    <xsd:element name="Has_Teacher_Only_SectionGroup" ma:index="25" nillable="true" ma:displayName="Has Teacher Only SectionGroup" ma:internalName="Has_Teacher_Only_SectionGroup">
-      <xsd:simpleType>
-        <xsd:restriction base="dms:Boolean"/>
-      </xsd:simpleType>
-    </xsd:element>
-    <xsd:element name="Is_Collaboration_Space_Locked" ma:index="26" nillable="true" ma:displayName="Is Collaboration Space Locked" ma:internalName="Is_Collaboration_Space_Locked">
-      <xsd:simpleType>
-        <xsd:restriction base="dms:Boolean"/>
-      </xsd:simpleType>
-    </xsd:element>
-    <xsd:element name="IsNotebookLocked" ma:index="27" nillable="true" ma:displayName="Is Notebook Locked" ma:internalName="IsNotebookLocked">
-      <xsd:simpleType>
-        <xsd:restriction base="dms:Boolean"/>
-      </xsd:simpleType>
-    </xsd:element>
-    <xsd:element name="Teams_Channel_Section_Location" ma:index="28" nillable="true" ma:displayName="Teams Channel Section Location" ma:internalName="Teams_Channel_Section_Location">
-      <xsd:simpleType>
-        <xsd:restriction base="dms:Text"/>
-      </xsd:simpleType>
-    </xsd:element>
-    <xsd:element name="MediaServiceMetadata" ma:index="29" nillable="true" ma:displayName="MediaServiceMetadata" ma:hidden="true" ma:internalName="MediaServiceMetadata" ma:readOnly="true">
-      <xsd:simpleType>
-        <xsd:restriction base="dms:Note"/>
-      </xsd:simpleType>
-    </xsd:element>
-    <xsd:element name="MediaServiceFastMetadata" ma:index="30" nillable="true" ma:displayName="MediaServiceFastMetadata" ma:hidden="true" ma:internalName="MediaServiceFastMetadata" ma:readOnly="true">
-      <xsd:simpleType>
-        <xsd:restriction base="dms:Note"/>
-      </xsd:simpleType>
-    </xsd:element>
-    <xsd:element name="MediaServiceSearchProperties" ma:index="31" nillable="true" ma:displayName="MediaServiceSearchProperties" ma:hidden="true" ma:internalName="MediaServiceSearchProperties" ma:readOnly="true">
-      <xsd:simpleType>
-        <xsd:restriction base="dms:Note"/>
-      </xsd:simpleType>
-    </xsd:element>
-    <xsd:element name="MediaServiceDateTaken" ma:index="32" nillable="true" ma:displayName="MediaServiceDateTaken" ma:hidden="true" ma:indexed="true" ma:internalName="MediaServiceDateTaken" ma:readOnly="true">
-      <xsd:simpleType>
-        <xsd:restriction base="dms:Text"/>
-      </xsd:simpleType>
-    </xsd:element>
-    <xsd:element name="MediaServiceGenerationTime" ma:index="33" nillable="true" ma:displayName="MediaServiceGenerationTime" ma:hidden="true" ma:internalName="MediaServiceGenerationTime" ma:readOnly="true">
-      <xsd:simpleType>
-        <xsd:restriction base="dms:Text"/>
-      </xsd:simpleType>
-    </xsd:element>
-    <xsd:element name="MediaServiceEventHashCode" ma:index="34" nillable="true" ma:displayName="MediaServiceEventHashCode" ma:hidden="true" ma:internalName="MediaServiceEventHashCode" ma:readOnly="true">
-      <xsd:simpleType>
-        <xsd:restriction base="dms:Text"/>
-      </xsd:simpleType>
-    </xsd:element>
-    <xsd:element name="MediaLengthInSeconds" ma:index="35" nillable="true" ma:displayName="MediaLengthInSeconds" ma:hidden="true" ma:internalName="MediaLengthInSeconds" ma:readOnly="true">
-      <xsd:simpleType>
-        <xsd:restriction base="dms:Unknown"/>
-      </xsd:simpleType>
-    </xsd:element>
-    <xsd:element name="lcf76f155ced4ddcb4097134ff3c332f" ma:index="37" nillable="true" ma:taxonomy="true" ma:internalName="lcf76f155ced4ddcb4097134ff3c332f" ma:taxonomyFieldName="MediaServiceImageTags" ma:displayName="Image Tags" ma:readOnly="false" ma:fieldId="{5cf76f15-5ced-4ddc-b409-7134ff3c332f}" ma:taxonomyMulti="true" ma:sspId="eb8cb680-6a83-4177-80f4-b15e2230c4d8" ma:termSetId="09814cd3-568e-fe90-9814-8d621ff8fb84" ma:anchorId="fba54fb3-c3e1-fe81-a776-ca4b69148c4d" ma:open="true" ma:isKeyword="false">
-      <xsd:complexType>
-        <xsd:sequence>
-          <xsd:element ref="pc:Terms" minOccurs="0" maxOccurs="1"/>
-        </xsd:sequence>
-      </xsd:complexType>
-    </xsd:element>
-    <xsd:element name="MediaServiceOCR" ma:index="39" nillable="true" ma:displayName="Extracted Text" ma:internalName="MediaServiceOCR" ma:readOnly="true">
-      <xsd:simpleType>
-        <xsd:restriction base="dms:Note">
-          <xsd:maxLength value="255"/>
-        </xsd:restriction>
-      </xsd:simpleType>
-    </xsd:element>
-  </xsd:schema>
-  <xsd:schema xmlns:xsd="http://www.w3.org/2001/XMLSchema" xmlns:xs="http://www.w3.org/2001/XMLSchema" xmlns:dms="http://schemas.microsoft.com/office/2006/documentManagement/types" xmlns:pc="http://schemas.microsoft.com/office/infopath/2007/PartnerControls" targetNamespace="9e209dda-a78e-49a0-9b2f-f7ca81c34b7c" elementFormDefault="qualified">
-    <xsd:import namespace="http://schemas.microsoft.com/office/2006/documentManagement/types"/>
-    <xsd:import namespace="http://schemas.microsoft.com/office/infopath/2007/PartnerControls"/>
-    <xsd:element name="TaxCatchAll" ma:index="38" nillable="true" ma:displayName="Taxonomy Catch All Column" ma:hidden="true" ma:list="{a0018add-e23d-4441-b071-bb6fc52e56ca}" ma:internalName="TaxCatchAll" ma:showField="CatchAllData" ma:web="9e209dda-a78e-49a0-9b2f-f7ca81c34b7c">
-      <xsd:complexType>
-        <xsd:complexContent>
-          <xsd:extension base="dms:MultiChoiceLookup">
-            <xsd:sequence>
-              <xsd:element name="Value" type="dms:Lookup" maxOccurs="unbounded" minOccurs="0" nillable="true"/>
-            </xsd:sequence>
-          </xsd:extension>
-        </xsd:complexContent>
-      </xsd:complexType>
-    </xsd:element>
-  </xsd:schema>
-  <xsd:schema xmlns="http://schemas.openxmlformats.org/package/2006/metadata/core-properties" xmlns:xsd="http://www.w3.org/2001/XMLSchema" xmlns:xsi="http://www.w3.org/2001/XMLSchema-instance" xmlns:dc="http://purl.org/dc/elements/1.1/" xmlns:dcterms="http://purl.org/dc/terms/" xmlns:odoc="http://schemas.microsoft.com/internal/obd" targetNamespace="http://schemas.openxmlformats.org/package/2006/metadata/core-properties" elementFormDefault="qualified" attributeFormDefault="unqualified" blockDefault="#all">
-    <xsd:import namespace="http://purl.org/dc/elements/1.1/" schemaLocation="http://dublincore.org/schemas/xmls/qdc/2003/04/02/dc.xsd"/>
-    <xsd:import namespace="http://purl.org/dc/terms/" schemaLocation="http://dublincore.org/schemas/xmls/qdc/2003/04/02/dcterms.xsd"/>
-    <xsd:element name="coreProperties" type="CT_coreProperties"/>
-    <xsd:complexType name="CT_coreProperties">
-      <xsd:all>
-        <xsd:element ref="dc:creator" minOccurs="0" maxOccurs="1"/>
-        <xsd:element ref="dcterms:created" minOccurs="0" maxOccurs="1"/>
-        <xsd:element ref="dc:identifier" minOccurs="0" maxOccurs="1"/>
-        <xsd:element name="contentType" minOccurs="0" maxOccurs="1" type="xsd:string" ma:index="0" ma:displayName="Content Type"/>
-        <xsd:element ref="dc:title" minOccurs="0" maxOccurs="1" ma:index="4" ma:displayName="Title"/>
-        <xsd:element ref="dc:subject" minOccurs="0" maxOccurs="1"/>
-        <xsd:element ref="dc:description" minOccurs="0" maxOccurs="1"/>
-        <xsd:element name="keywords" minOccurs="0" maxOccurs="1" type="xsd:string"/>
-        <xsd:element ref="dc:language" minOccurs="0" maxOccurs="1"/>
-        <xsd:element name="category" minOccurs="0" maxOccurs="1" type="xsd:string"/>
-        <xsd:element name="version" minOccurs="0" maxOccurs="1" type="xsd:string"/>
-        <xsd:element name="revision" minOccurs="0" maxOccurs="1" type="xsd:string">
-          <xsd:annotation>
-            <xsd:documentation>
-                        This value indicates the number of saves or revisions. The application is responsible for updating this value after each revision.
-                    </xsd:documentation>
-          </xsd:annotation>
-        </xsd:element>
-        <xsd:element name="lastModifiedBy" minOccurs="0" maxOccurs="1" type="xsd:string"/>
-        <xsd:element ref="dcterms:modified" minOccurs="0" maxOccurs="1"/>
-        <xsd:element name="contentStatus" minOccurs="0" maxOccurs="1" type="xsd:string"/>
-      </xsd:all>
-    </xsd:complexType>
-  </xsd:schema>
-  <xs:schema xmlns:pc="http://schemas.microsoft.com/office/infopath/2007/PartnerControls" xmlns:xs="http://www.w3.org/2001/XMLSchema" targetNamespace="http://schemas.microsoft.com/office/infopath/2007/PartnerControls" elementFormDefault="qualified" attributeFormDefault="unqualified">
-    <xs:element name="Person">
-      <xs:complexType>
-        <xs:sequence>
-          <xs:element ref="pc:DisplayName" minOccurs="0"/>
-          <xs:element ref="pc:AccountId" minOccurs="0"/>
-          <xs:element ref="pc:AccountType" minOccurs="0"/>
-        </xs:sequence>
-      </xs:complexType>
-    </xs:element>
-    <xs:element name="DisplayName" type="xs:string"/>
-    <xs:element name="AccountId" type="xs:string"/>
-    <xs:element name="AccountType" type="xs:string"/>
-    <xs:element name="BDCAssociatedEntity">
-      <xs:complexType>
-        <xs:sequence>
-          <xs:element ref="pc:BDCEntity" minOccurs="0" maxOccurs="unbounded"/>
-        </xs:sequence>
-        <xs:attribute ref="pc:EntityNamespace"/>
-        <xs:attribute ref="pc:EntityName"/>
-        <xs:attribute ref="pc:SystemInstanceName"/>
-        <xs:attribute ref="pc:AssociationName"/>
-      </xs:complexType>
-    </xs:element>
-    <xs:attribute name="EntityNamespace" type="xs:string"/>
-    <xs:attribute name="EntityName" type="xs:string"/>
-    <xs:attribute name="SystemInstanceName" type="xs:string"/>
-    <xs:attribute name="AssociationName" type="xs:string"/>
-    <xs:element name="BDCEntity">
-      <xs:complexType>
-        <xs:sequence>
-          <xs:element ref="pc:EntityDisplayName" minOccurs="0"/>
-          <xs:element ref="pc:EntityInstanceReference" minOccurs="0"/>
-          <xs:element ref="pc:EntityId1" minOccurs="0"/>
-          <xs:element ref="pc:EntityId2" minOccurs="0"/>
-          <xs:element ref="pc:EntityId3" minOccurs="0"/>
-          <xs:element ref="pc:EntityId4" minOccurs="0"/>
-          <xs:element ref="pc:EntityId5" minOccurs="0"/>
-        </xs:sequence>
-      </xs:complexType>
-    </xs:element>
-    <xs:element name="EntityDisplayName" type="xs:string"/>
-    <xs:element name="EntityInstanceReference" type="xs:string"/>
-    <xs:element name="EntityId1" type="xs:string"/>
-    <xs:element name="EntityId2" type="xs:string"/>
-    <xs:element name="EntityId3" type="xs:string"/>
-    <xs:element name="EntityId4" type="xs:string"/>
-    <xs:element name="EntityId5" type="xs:string"/>
-    <xs:element name="Terms">
-      <xs:complexType>
-        <xs:sequence>
-          <xs:element ref="pc:TermInfo" minOccurs="0" maxOccurs="unbounded"/>
-        </xs:sequence>
-      </xs:complexType>
-    </xs:element>
-    <xs:element name="TermInfo">
-      <xs:complexType>
-        <xs:sequence>
-          <xs:element ref="pc:TermName" minOccurs="0"/>
-          <xs:element ref="pc:TermId" minOccurs="0"/>
-        </xs:sequence>
-      </xs:complexType>
-    </xs:element>
-    <xs:element name="TermName" type="xs:string"/>
-    <xs:element name="TermId" type="xs:string"/>
-  </xs:schema>
-</ct:contentTypeSchema>
-</file>
-
-<file path=customXml/item2.xml><?xml version="1.0" encoding="utf-8"?>
-<?mso-contentType ?>
-<FormTemplates xmlns="http://schemas.microsoft.com/sharepoint/v3/contenttype/forms">
-  <Display>DocumentLibraryForm</Display>
-  <Edit>DocumentLibraryForm</Edit>
-  <New>DocumentLibraryForm</New>
-</FormTemplates>
-</file>
-
-<file path=customXml/item3.xml><?xml version="1.0" encoding="utf-8"?>
-<p:properties xmlns:p="http://schemas.microsoft.com/office/2006/metadata/properties" xmlns:xsi="http://www.w3.org/2001/XMLSchema-instance" xmlns:pc="http://schemas.microsoft.com/office/infopath/2007/PartnerControls">
-  <documentManagement>
-    <Self_Registration_Enabled xmlns="921d7e3d-ccf6-4c0a-83b2-6e8132303dda" xsi:nil="true"/>
-    <DefaultSectionNames xmlns="921d7e3d-ccf6-4c0a-83b2-6e8132303dda" xsi:nil="true"/>
-    <Is_Collaboration_Space_Locked xmlns="921d7e3d-ccf6-4c0a-83b2-6e8132303dda" xsi:nil="true"/>
-    <Teams_Channel_Section_Location xmlns="921d7e3d-ccf6-4c0a-83b2-6e8132303dda" xsi:nil="true"/>
-    <AppVersion xmlns="921d7e3d-ccf6-4c0a-83b2-6e8132303dda" xsi:nil="true"/>
-    <LMS_Mappings xmlns="921d7e3d-ccf6-4c0a-83b2-6e8132303dda" xsi:nil="true"/>
-    <Invited_Students xmlns="921d7e3d-ccf6-4c0a-83b2-6e8132303dda" xsi:nil="true"/>
-    <Math_Settings xmlns="921d7e3d-ccf6-4c0a-83b2-6e8132303dda" xsi:nil="true"/>
-    <Templates xmlns="921d7e3d-ccf6-4c0a-83b2-6e8132303dda" xsi:nil="true"/>
-    <FolderType xmlns="921d7e3d-ccf6-4c0a-83b2-6e8132303dda" xsi:nil="true"/>
-    <Owner xmlns="921d7e3d-ccf6-4c0a-83b2-6e8132303dda">
-      <UserInfo>
-        <DisplayName/>
-        <AccountId xsi:nil="true"/>
-        <AccountType/>
-      </UserInfo>
-    </Owner>
-    <Teachers xmlns="921d7e3d-ccf6-4c0a-83b2-6e8132303dda">
-      <UserInfo>
-        <DisplayName/>
-        <AccountId xsi:nil="true"/>
-        <AccountType/>
-      </UserInfo>
-    </Teachers>
-    <Students xmlns="921d7e3d-ccf6-4c0a-83b2-6e8132303dda">
-      <UserInfo>
-        <DisplayName/>
-        <AccountId xsi:nil="true"/>
-        <AccountType/>
-      </UserInfo>
-    </Students>
-    <Student_Groups xmlns="921d7e3d-ccf6-4c0a-83b2-6e8132303dda">
-      <UserInfo>
-        <DisplayName/>
-        <AccountId xsi:nil="true"/>
-        <AccountType/>
-      </UserInfo>
-    </Student_Groups>
-    <Distribution_Groups xmlns="921d7e3d-ccf6-4c0a-83b2-6e8132303dda" xsi:nil="true"/>
-    <TeamsChannelId xmlns="921d7e3d-ccf6-4c0a-83b2-6e8132303dda" xsi:nil="true"/>
-    <IsNotebookLocked xmlns="921d7e3d-ccf6-4c0a-83b2-6e8132303dda" xsi:nil="true"/>
-    <NotebookType xmlns="921d7e3d-ccf6-4c0a-83b2-6e8132303dda" xsi:nil="true"/>
-    <CultureName xmlns="921d7e3d-ccf6-4c0a-83b2-6e8132303dda" xsi:nil="true"/>
-    <Invited_Teachers xmlns="921d7e3d-ccf6-4c0a-83b2-6e8132303dda" xsi:nil="true"/>
-    <Has_Teacher_Only_SectionGroup xmlns="921d7e3d-ccf6-4c0a-83b2-6e8132303dda" xsi:nil="true"/>
-    <lcf76f155ced4ddcb4097134ff3c332f xmlns="921d7e3d-ccf6-4c0a-83b2-6e8132303dda">
-      <Terms xmlns="http://schemas.microsoft.com/office/infopath/2007/PartnerControls"/>
-    </lcf76f155ced4ddcb4097134ff3c332f>
-    <TaxCatchAll xmlns="9e209dda-a78e-49a0-9b2f-f7ca81c34b7c" xsi:nil="true"/>
-  </documentManagement>
-</p:properties>
-</file>
-
-<file path=customXml/itemProps1.xml><?xml version="1.0" encoding="utf-8"?>
-<ds:datastoreItem xmlns:ds="http://schemas.openxmlformats.org/officeDocument/2006/customXml" ds:itemID="{A0AC68F8-1551-41D1-BC45-1878937B4334}"/>
-</file>
-
-<file path=customXml/itemProps2.xml><?xml version="1.0" encoding="utf-8"?>
-<ds:datastoreItem xmlns:ds="http://schemas.openxmlformats.org/officeDocument/2006/customXml" ds:itemID="{B87039D2-A9D2-4BDE-A00C-41219E70FCDF}"/>
-</file>
-
-<file path=customXml/itemProps3.xml><?xml version="1.0" encoding="utf-8"?>
-<ds:datastoreItem xmlns:ds="http://schemas.openxmlformats.org/officeDocument/2006/customXml" ds:itemID="{0C62A5A7-7378-4E45-A001-C8EB78D9B0FC}"/>
-</file>
-
 <file path=docMetadata/LabelInfo.xml><?xml version="1.0" encoding="utf-8"?>
 <clbl:labelList xmlns:clbl="http://schemas.microsoft.com/office/2020/mipLabelMetadata">
   <clbl:label id="{87ba5c36-b7cf-4793-bbc2-bd5b3a9f95ca}" enabled="1" method="Privileged" siteId="{72f988bf-86f1-41af-91ab-2d7cd011db47}" contentBits="0" removed="0"/>

</xml_diff>